<commit_message>
Migrate positional model ids to baseline and learnable position
</commit_message>
<xml_diff>
--- a/results/cadb_elements_positional_100e/reports/cadb_elements_positional_8models_report/cadb_elements_positional_8models_report.pptx
+++ b/results/cadb_elements_positional_100e/reports/cadb_elements_positional_8models_report/cadb_elements_positional_8models_report.pptx
@@ -3207,7 +3207,7 @@
                 </a:solidFill>
                 <a:latin typeface="Aptos"/>
               </a:rPr>
-              <a:t>CADB Multi-label Positional Encoding Comparison (8 Models)</a:t>
+              <a:t>CADB Elements Positional Encoding Comparison</a:t>
             </a:r>
           </a:p>
         </p:txBody>
@@ -3342,7 +3342,7 @@
                 </a:solidFill>
                 <a:latin typeface="Aptos"/>
               </a:rPr>
-              <a:t>ViT No Pos</a:t>
+              <a:t>ViT Baseline (No Pos)</a:t>
             </a:r>
           </a:p>
         </p:txBody>
@@ -3432,7 +3432,7 @@
                 </a:solidFill>
                 <a:latin typeface="Aptos"/>
               </a:rPr>
-              <a:t>ViT Baseline</a:t>
+              <a:t>ViT Learnable Position</a:t>
             </a:r>
           </a:p>
         </p:txBody>
@@ -3522,7 +3522,7 @@
                 </a:solidFill>
                 <a:latin typeface="Aptos"/>
               </a:rPr>
-              <a:t>ViT Row-wise</a:t>
+              <a:t>ViT Row-wise Sinusoidal</a:t>
             </a:r>
           </a:p>
         </p:txBody>
@@ -3612,7 +3612,7 @@
                 </a:solidFill>
                 <a:latin typeface="Aptos"/>
               </a:rPr>
-              <a:t>ViT Column-wise</a:t>
+              <a:t>ViT Column-wise Sinusoidal</a:t>
             </a:r>
           </a:p>
         </p:txBody>
@@ -3763,7 +3763,7 @@
                 </a:solidFill>
                 <a:latin typeface="Aptos"/>
               </a:rPr>
-              <a:t>Reference run: ViT No Pos</a:t>
+              <a:t>Reference run: ViT Baseline (No Pos)</a:t>
             </a:r>
           </a:p>
           <a:p>
@@ -3846,7 +3846,7 @@
                 </a:solidFill>
                 <a:latin typeface="Aptos"/>
               </a:rPr>
-              <a:t>Generated 2026-07-01 16:11</a:t>
+              <a:t>Generated 2026-07-04 15:12</a:t>
             </a:r>
           </a:p>
         </p:txBody>
@@ -4241,7 +4241,7 @@
                           </a:solidFill>
                           <a:latin typeface="Aptos"/>
                         </a:rPr>
-                        <a:t>ViT Additive</a:t>
+                        <a:t>ViT Additive Sinusoidal</a:t>
                       </a:r>
                     </a:p>
                   </a:txBody>
@@ -4268,7 +4268,7 @@
                           </a:solidFill>
                           <a:latin typeface="Aptos"/>
                         </a:rPr>
-                        <a:t>ViT Additive Shifted</a:t>
+                        <a:t>ViT Additive Sinusoidal Shifted</a:t>
                       </a:r>
                     </a:p>
                   </a:txBody>
@@ -4295,7 +4295,7 @@
                           </a:solidFill>
                           <a:latin typeface="Aptos"/>
                         </a:rPr>
-                        <a:t>ViT Multiplicative</a:t>
+                        <a:t>ViT Multiplicative Sinusoidal</a:t>
                       </a:r>
                     </a:p>
                   </a:txBody>
@@ -4322,7 +4322,7 @@
                           </a:solidFill>
                           <a:latin typeface="Aptos"/>
                         </a:rPr>
-                        <a:t>ViT Multiplicative Shifted</a:t>
+                        <a:t>ViT Multiplicative Sinusoidal Shifted</a:t>
                       </a:r>
                     </a:p>
                   </a:txBody>
@@ -6119,7 +6119,7 @@
                           </a:solidFill>
                           <a:latin typeface="Aptos"/>
                         </a:rPr>
-                        <a:t>ViT No Pos</a:t>
+                        <a:t>ViT Baseline (No Pos)</a:t>
                       </a:r>
                     </a:p>
                   </a:txBody>
@@ -6202,7 +6202,7 @@
                           </a:solidFill>
                           <a:latin typeface="Aptos"/>
                         </a:rPr>
-                        <a:t>ViT Row-wise</a:t>
+                        <a:t>ViT Row-wise Sinusoidal</a:t>
                       </a:r>
                     </a:p>
                   </a:txBody>
@@ -6285,7 +6285,7 @@
                           </a:solidFill>
                           <a:latin typeface="Aptos"/>
                         </a:rPr>
-                        <a:t>ViT Multiplicative</a:t>
+                        <a:t>ViT Multiplicative Sinusoidal</a:t>
                       </a:r>
                     </a:p>
                   </a:txBody>
@@ -6368,7 +6368,7 @@
                           </a:solidFill>
                           <a:latin typeface="Aptos"/>
                         </a:rPr>
-                        <a:t>ViT Column-wise</a:t>
+                        <a:t>ViT Column-wise Sinusoidal</a:t>
                       </a:r>
                     </a:p>
                   </a:txBody>
@@ -6451,7 +6451,7 @@
                           </a:solidFill>
                           <a:latin typeface="Aptos"/>
                         </a:rPr>
-                        <a:t>ViT Row-wise</a:t>
+                        <a:t>ViT Row-wise Sinusoidal</a:t>
                       </a:r>
                     </a:p>
                   </a:txBody>
@@ -6534,7 +6534,7 @@
                           </a:solidFill>
                           <a:latin typeface="Aptos"/>
                         </a:rPr>
-                        <a:t>ViT No Pos</a:t>
+                        <a:t>ViT Baseline (No Pos)</a:t>
                       </a:r>
                     </a:p>
                   </a:txBody>
@@ -6617,7 +6617,7 @@
                           </a:solidFill>
                           <a:latin typeface="Aptos"/>
                         </a:rPr>
-                        <a:t>ViT Row-wise</a:t>
+                        <a:t>ViT Row-wise Sinusoidal</a:t>
                       </a:r>
                     </a:p>
                   </a:txBody>
@@ -6700,7 +6700,7 @@
                           </a:solidFill>
                           <a:latin typeface="Aptos"/>
                         </a:rPr>
-                        <a:t>ViT Multiplicative Shifted</a:t>
+                        <a:t>ViT Multiplicative Sinusoidal Shifted</a:t>
                       </a:r>
                     </a:p>
                   </a:txBody>
@@ -7105,7 +7105,7 @@
                           </a:solidFill>
                           <a:latin typeface="Aptos"/>
                         </a:rPr>
-                        <a:t>ViT No Pos</a:t>
+                        <a:t>ViT Baseline (No Pos)</a:t>
                       </a:r>
                     </a:p>
                   </a:txBody>
@@ -7132,7 +7132,7 @@
                           </a:solidFill>
                           <a:latin typeface="Aptos"/>
                         </a:rPr>
-                        <a:t>ViT Baseline</a:t>
+                        <a:t>ViT Learnable Position</a:t>
                       </a:r>
                     </a:p>
                   </a:txBody>
@@ -7159,7 +7159,7 @@
                           </a:solidFill>
                           <a:latin typeface="Aptos"/>
                         </a:rPr>
-                        <a:t>ViT Row-wise</a:t>
+                        <a:t>ViT Row-wise Sinusoidal</a:t>
                       </a:r>
                     </a:p>
                   </a:txBody>
@@ -7186,7 +7186,7 @@
                           </a:solidFill>
                           <a:latin typeface="Aptos"/>
                         </a:rPr>
-                        <a:t>ViT Column-wise</a:t>
+                        <a:t>ViT Column-wise Sinusoidal</a:t>
                       </a:r>
                     </a:p>
                   </a:txBody>
@@ -8575,7 +8575,7 @@
                           </a:solidFill>
                           <a:latin typeface="Aptos"/>
                         </a:rPr>
-                        <a:t>ViT Additive</a:t>
+                        <a:t>ViT Additive Sinusoidal</a:t>
                       </a:r>
                     </a:p>
                   </a:txBody>
@@ -8602,7 +8602,7 @@
                           </a:solidFill>
                           <a:latin typeface="Aptos"/>
                         </a:rPr>
-                        <a:t>ViT Additive Shifted</a:t>
+                        <a:t>ViT Additive Sinusoidal Shifted</a:t>
                       </a:r>
                     </a:p>
                   </a:txBody>
@@ -8629,7 +8629,7 @@
                           </a:solidFill>
                           <a:latin typeface="Aptos"/>
                         </a:rPr>
-                        <a:t>ViT Multiplicative</a:t>
+                        <a:t>ViT Multiplicative Sinusoidal</a:t>
                       </a:r>
                     </a:p>
                   </a:txBody>
@@ -8656,7 +8656,7 @@
                           </a:solidFill>
                           <a:latin typeface="Aptos"/>
                         </a:rPr>
-                        <a:t>ViT Multiplicative Shifted</a:t>
+                        <a:t>ViT Multiplicative Sinusoidal Shifted</a:t>
                       </a:r>
                     </a:p>
                   </a:txBody>
@@ -10125,7 +10125,7 @@
                           </a:solidFill>
                           <a:latin typeface="Aptos"/>
                         </a:rPr>
-                        <a:t>ViT Multiplicative</a:t>
+                        <a:t>ViT Multiplicative Sinusoidal</a:t>
                       </a:r>
                     </a:p>
                   </a:txBody>
@@ -10208,7 +10208,7 @@
                           </a:solidFill>
                           <a:latin typeface="Aptos"/>
                         </a:rPr>
-                        <a:t>ViT Baseline</a:t>
+                        <a:t>ViT Learnable Position</a:t>
                       </a:r>
                     </a:p>
                   </a:txBody>
@@ -10291,7 +10291,7 @@
                           </a:solidFill>
                           <a:latin typeface="Aptos"/>
                         </a:rPr>
-                        <a:t>ViT Additive Shifted</a:t>
+                        <a:t>ViT Additive Sinusoidal Shifted</a:t>
                       </a:r>
                     </a:p>
                   </a:txBody>
@@ -10374,7 +10374,7 @@
                           </a:solidFill>
                           <a:latin typeface="Aptos"/>
                         </a:rPr>
-                        <a:t>ViT Column-wise</a:t>
+                        <a:t>ViT Column-wise Sinusoidal</a:t>
                       </a:r>
                     </a:p>
                   </a:txBody>
@@ -10457,7 +10457,7 @@
                           </a:solidFill>
                           <a:latin typeface="Aptos"/>
                         </a:rPr>
-                        <a:t>ViT Multiplicative Shifted</a:t>
+                        <a:t>ViT Multiplicative Sinusoidal Shifted</a:t>
                       </a:r>
                     </a:p>
                   </a:txBody>
@@ -10540,7 +10540,7 @@
                           </a:solidFill>
                           <a:latin typeface="Aptos"/>
                         </a:rPr>
-                        <a:t>ViT Row-wise</a:t>
+                        <a:t>ViT Row-wise Sinusoidal</a:t>
                       </a:r>
                     </a:p>
                   </a:txBody>
@@ -10945,7 +10945,7 @@
                           </a:solidFill>
                           <a:latin typeface="Aptos"/>
                         </a:rPr>
-                        <a:t>ViT No Pos</a:t>
+                        <a:t>ViT Baseline (No Pos)</a:t>
                       </a:r>
                     </a:p>
                   </a:txBody>
@@ -10972,7 +10972,7 @@
                           </a:solidFill>
                           <a:latin typeface="Aptos"/>
                         </a:rPr>
-                        <a:t>ViT Baseline</a:t>
+                        <a:t>ViT Learnable Position</a:t>
                       </a:r>
                     </a:p>
                   </a:txBody>
@@ -10999,7 +10999,7 @@
                           </a:solidFill>
                           <a:latin typeface="Aptos"/>
                         </a:rPr>
-                        <a:t>ViT Row-wise</a:t>
+                        <a:t>ViT Row-wise Sinusoidal</a:t>
                       </a:r>
                     </a:p>
                   </a:txBody>
@@ -11026,7 +11026,7 @@
                           </a:solidFill>
                           <a:latin typeface="Aptos"/>
                         </a:rPr>
-                        <a:t>ViT Column-wise</a:t>
+                        <a:t>ViT Column-wise Sinusoidal</a:t>
                       </a:r>
                     </a:p>
                   </a:txBody>
@@ -12415,7 +12415,7 @@
                           </a:solidFill>
                           <a:latin typeface="Aptos"/>
                         </a:rPr>
-                        <a:t>ViT Additive</a:t>
+                        <a:t>ViT Additive Sinusoidal</a:t>
                       </a:r>
                     </a:p>
                   </a:txBody>
@@ -12442,7 +12442,7 @@
                           </a:solidFill>
                           <a:latin typeface="Aptos"/>
                         </a:rPr>
-                        <a:t>ViT Additive Shifted</a:t>
+                        <a:t>ViT Additive Sinusoidal Shifted</a:t>
                       </a:r>
                     </a:p>
                   </a:txBody>
@@ -12469,7 +12469,7 @@
                           </a:solidFill>
                           <a:latin typeface="Aptos"/>
                         </a:rPr>
-                        <a:t>ViT Multiplicative</a:t>
+                        <a:t>ViT Multiplicative Sinusoidal</a:t>
                       </a:r>
                     </a:p>
                   </a:txBody>
@@ -12496,7 +12496,7 @@
                           </a:solidFill>
                           <a:latin typeface="Aptos"/>
                         </a:rPr>
-                        <a:t>ViT Multiplicative Shifted</a:t>
+                        <a:t>ViT Multiplicative Sinusoidal Shifted</a:t>
                       </a:r>
                     </a:p>
                   </a:txBody>
@@ -13965,7 +13965,7 @@
                           </a:solidFill>
                           <a:latin typeface="Aptos"/>
                         </a:rPr>
-                        <a:t>ViT Multiplicative Shifted</a:t>
+                        <a:t>ViT Multiplicative Sinusoidal Shifted</a:t>
                       </a:r>
                     </a:p>
                   </a:txBody>
@@ -14048,7 +14048,7 @@
                           </a:solidFill>
                           <a:latin typeface="Aptos"/>
                         </a:rPr>
-                        <a:t>ViT Multiplicative</a:t>
+                        <a:t>ViT Multiplicative Sinusoidal</a:t>
                       </a:r>
                     </a:p>
                   </a:txBody>
@@ -14131,7 +14131,7 @@
                           </a:solidFill>
                           <a:latin typeface="Aptos"/>
                         </a:rPr>
-                        <a:t>ViT Baseline</a:t>
+                        <a:t>ViT Learnable Position</a:t>
                       </a:r>
                     </a:p>
                   </a:txBody>
@@ -14214,7 +14214,7 @@
                           </a:solidFill>
                           <a:latin typeface="Aptos"/>
                         </a:rPr>
-                        <a:t>ViT Row-wise</a:t>
+                        <a:t>ViT Row-wise Sinusoidal</a:t>
                       </a:r>
                     </a:p>
                   </a:txBody>
@@ -14297,7 +14297,7 @@
                           </a:solidFill>
                           <a:latin typeface="Aptos"/>
                         </a:rPr>
-                        <a:t>ViT Additive Shifted</a:t>
+                        <a:t>ViT Additive Sinusoidal Shifted</a:t>
                       </a:r>
                     </a:p>
                   </a:txBody>
@@ -14380,7 +14380,7 @@
                           </a:solidFill>
                           <a:latin typeface="Aptos"/>
                         </a:rPr>
-                        <a:t>ViT Column-wise</a:t>
+                        <a:t>ViT Column-wise Sinusoidal</a:t>
                       </a:r>
                     </a:p>
                   </a:txBody>
@@ -14881,7 +14881,7 @@
                 </a:solidFill>
                 <a:latin typeface="Aptos"/>
               </a:rPr>
-              <a:t>Best Test Macro F1 snapshot: ViT Additive (34.95%).</a:t>
+              <a:t>Best Test Macro F1 snapshot: ViT Additive Sinusoidal (34.95%).</a:t>
             </a:r>
           </a:p>
           <a:p>
@@ -14900,7 +14900,7 @@
                 </a:solidFill>
                 <a:latin typeface="Aptos"/>
               </a:rPr>
-              <a:t>Best selected Test Macro Precision: ViT Multiplicative (38.52%).</a:t>
+              <a:t>Best selected Test Macro Precision: ViT Multiplicative Sinusoidal (38.52%).</a:t>
             </a:r>
           </a:p>
           <a:p>
@@ -14919,7 +14919,7 @@
                 </a:solidFill>
                 <a:latin typeface="Aptos"/>
               </a:rPr>
-              <a:t>Best selected Test Macro Recall: ViT Baseline (34.80%).</a:t>
+              <a:t>Best selected Test Macro Recall: ViT Learnable Position (34.80%).</a:t>
             </a:r>
           </a:p>
         </p:txBody>
@@ -15286,7 +15286,7 @@
                           </a:solidFill>
                           <a:latin typeface="Aptos"/>
                         </a:rPr>
-                        <a:t>ViT No Pos</a:t>
+                        <a:t>ViT Baseline (No Pos)</a:t>
                       </a:r>
                     </a:p>
                   </a:txBody>
@@ -15313,7 +15313,7 @@
                           </a:solidFill>
                           <a:latin typeface="Aptos"/>
                         </a:rPr>
-                        <a:t>ViT Baseline</a:t>
+                        <a:t>ViT Learnable Position</a:t>
                       </a:r>
                     </a:p>
                   </a:txBody>
@@ -15340,7 +15340,7 @@
                           </a:solidFill>
                           <a:latin typeface="Aptos"/>
                         </a:rPr>
-                        <a:t>ViT Row-wise</a:t>
+                        <a:t>ViT Row-wise Sinusoidal</a:t>
                       </a:r>
                     </a:p>
                   </a:txBody>
@@ -15367,7 +15367,7 @@
                           </a:solidFill>
                           <a:latin typeface="Aptos"/>
                         </a:rPr>
-                        <a:t>ViT Column-wise</a:t>
+                        <a:t>ViT Column-wise Sinusoidal</a:t>
                       </a:r>
                     </a:p>
                   </a:txBody>
@@ -15560,7 +15560,7 @@
                           </a:solidFill>
                           <a:latin typeface="Aptos"/>
                         </a:rPr>
-                        <a:t>no_pos_cadb_elements_seed42</a:t>
+                        <a:t>baseline_cadb_elements_seed42</a:t>
                       </a:r>
                     </a:p>
                   </a:txBody>
@@ -15587,7 +15587,7 @@
                           </a:solidFill>
                           <a:latin typeface="Aptos"/>
                         </a:rPr>
-                        <a:t>baseline_cadb_elements_seed42</a:t>
+                        <a:t>learnable_position_cadb_elements_seed42</a:t>
                       </a:r>
                     </a:p>
                   </a:txBody>
@@ -16076,7 +16076,7 @@
                 </a:solidFill>
                 <a:latin typeface="Aptos"/>
               </a:rPr>
-              <a:t>ViT No Pos</a:t>
+              <a:t>ViT Baseline (No Pos)</a:t>
             </a:r>
           </a:p>
         </p:txBody>
@@ -16118,7 +16118,7 @@
                 </a:solidFill>
                 <a:latin typeface="Aptos"/>
               </a:rPr>
-              <a:t>Run ID: no_pos_cadb_elements_seed42</a:t>
+              <a:t>Run ID: baseline_cadb_elements_seed42</a:t>
             </a:r>
           </a:p>
           <a:p>
@@ -16137,7 +16137,7 @@
                 </a:solidFill>
                 <a:latin typeface="Aptos"/>
               </a:rPr>
-              <a:t>Model / device: ViT No Pos / cuda</a:t>
+              <a:t>Model / device: ViT Baseline (No Pos) / cuda</a:t>
             </a:r>
           </a:p>
           <a:p>
@@ -16175,7 +16175,7 @@
                 </a:solidFill>
                 <a:latin typeface="Aptos"/>
               </a:rPr>
-              <a:t>Family / variant: ViT / No Pos</a:t>
+              <a:t>Family / variant: ViT / Baseline (No Pos)</a:t>
             </a:r>
           </a:p>
           <a:p>
@@ -16346,7 +16346,7 @@
                 </a:solidFill>
                 <a:latin typeface="Aptos"/>
               </a:rPr>
-              <a:t>ViT Baseline</a:t>
+              <a:t>ViT Learnable Position</a:t>
             </a:r>
           </a:p>
         </p:txBody>
@@ -16388,7 +16388,7 @@
                 </a:solidFill>
                 <a:latin typeface="Aptos"/>
               </a:rPr>
-              <a:t>Run ID: baseline_cadb_elements_seed42</a:t>
+              <a:t>Run ID: learnable_position_cadb_elements_seed42</a:t>
             </a:r>
           </a:p>
           <a:p>
@@ -16407,7 +16407,7 @@
                 </a:solidFill>
                 <a:latin typeface="Aptos"/>
               </a:rPr>
-              <a:t>Model / device: ViT Baseline / cuda</a:t>
+              <a:t>Model / device: ViT Learnable Position / cuda</a:t>
             </a:r>
           </a:p>
           <a:p>
@@ -16445,7 +16445,7 @@
                 </a:solidFill>
                 <a:latin typeface="Aptos"/>
               </a:rPr>
-              <a:t>Family / variant: ViT / Baseline</a:t>
+              <a:t>Family / variant: ViT / Learnable Position</a:t>
             </a:r>
           </a:p>
           <a:p>
@@ -16616,7 +16616,7 @@
                 </a:solidFill>
                 <a:latin typeface="Aptos"/>
               </a:rPr>
-              <a:t>ViT Row-wise</a:t>
+              <a:t>ViT Row-wise Sinusoidal</a:t>
             </a:r>
           </a:p>
         </p:txBody>
@@ -16886,7 +16886,7 @@
                 </a:solidFill>
                 <a:latin typeface="Aptos"/>
               </a:rPr>
-              <a:t>ViT Column-wise</a:t>
+              <a:t>ViT Column-wise Sinusoidal</a:t>
             </a:r>
           </a:p>
         </p:txBody>
@@ -17435,7 +17435,7 @@
                           </a:solidFill>
                           <a:latin typeface="Aptos"/>
                         </a:rPr>
-                        <a:t>ViT Additive</a:t>
+                        <a:t>ViT Additive Sinusoidal</a:t>
                       </a:r>
                     </a:p>
                   </a:txBody>
@@ -17462,7 +17462,7 @@
                           </a:solidFill>
                           <a:latin typeface="Aptos"/>
                         </a:rPr>
-                        <a:t>ViT Additive Shifted</a:t>
+                        <a:t>ViT Additive Sinusoidal Shifted</a:t>
                       </a:r>
                     </a:p>
                   </a:txBody>
@@ -17489,7 +17489,7 @@
                           </a:solidFill>
                           <a:latin typeface="Aptos"/>
                         </a:rPr>
-                        <a:t>ViT Multiplicative</a:t>
+                        <a:t>ViT Multiplicative Sinusoidal</a:t>
                       </a:r>
                     </a:p>
                   </a:txBody>
@@ -17516,7 +17516,7 @@
                           </a:solidFill>
                           <a:latin typeface="Aptos"/>
                         </a:rPr>
-                        <a:t>ViT Multiplicative Shifted</a:t>
+                        <a:t>ViT Multiplicative Sinusoidal Shifted</a:t>
                       </a:r>
                     </a:p>
                   </a:txBody>
@@ -18206,7 +18206,7 @@
                 </a:solidFill>
                 <a:latin typeface="Aptos"/>
               </a:rPr>
-              <a:t>Best final value: ViT No Pos (79.48%)</a:t>
+              <a:t>Best final value: ViT Baseline (No Pos) (79.48%)</a:t>
             </a:r>
           </a:p>
         </p:txBody>
@@ -18320,7 +18320,7 @@
                 </a:solidFill>
                 <a:latin typeface="Aptos"/>
               </a:rPr>
-              <a:t>Best final value: ViT Row-wise (80.15%)</a:t>
+              <a:t>Best final value: ViT Row-wise Sinusoidal (80.15%)</a:t>
             </a:r>
           </a:p>
         </p:txBody>
@@ -18726,7 +18726,7 @@
                 </a:solidFill>
                 <a:latin typeface="Aptos"/>
               </a:rPr>
-              <a:t>Best final value: ViT Multiplicative (0.8988)</a:t>
+              <a:t>Best final value: ViT Multiplicative Sinusoidal (0.8988)</a:t>
             </a:r>
           </a:p>
         </p:txBody>
@@ -18840,7 +18840,7 @@
                 </a:solidFill>
                 <a:latin typeface="Aptos"/>
               </a:rPr>
-              <a:t>Best final value: ViT Column-wise (0.8815)</a:t>
+              <a:t>Best final value: ViT Column-wise Sinusoidal (0.8815)</a:t>
             </a:r>
           </a:p>
         </p:txBody>
@@ -19246,7 +19246,7 @@
                 </a:solidFill>
                 <a:latin typeface="Aptos"/>
               </a:rPr>
-              <a:t>Best final value: ViT Row-wise (99.96%)</a:t>
+              <a:t>Best final value: ViT Row-wise Sinusoidal (99.96%)</a:t>
             </a:r>
           </a:p>
         </p:txBody>
@@ -19360,7 +19360,7 @@
                 </a:solidFill>
                 <a:latin typeface="Aptos"/>
               </a:rPr>
-              <a:t>Best final value: ViT No Pos (0.0072)</a:t>
+              <a:t>Best final value: ViT Baseline (No Pos) (0.0072)</a:t>
             </a:r>
           </a:p>
         </p:txBody>
@@ -19766,7 +19766,7 @@
                 </a:solidFill>
                 <a:latin typeface="Aptos"/>
               </a:rPr>
-              <a:t>Best final value: ViT Row-wise (36.55%)</a:t>
+              <a:t>Best final value: ViT Row-wise Sinusoidal (36.55%)</a:t>
             </a:r>
           </a:p>
         </p:txBody>
@@ -19880,7 +19880,7 @@
                 </a:solidFill>
                 <a:latin typeface="Aptos"/>
               </a:rPr>
-              <a:t>Best final value: ViT Multiplicative Shifted (34.38%)</a:t>
+              <a:t>Best final value: ViT Multiplicative Sinusoidal Shifted (34.38%)</a:t>
             </a:r>
           </a:p>
         </p:txBody>
@@ -20371,7 +20371,7 @@
                 </a:solidFill>
                 <a:latin typeface="Aptos"/>
               </a:rPr>
-              <a:t>Highest mean Test Per Class Accuracy: ViT No Pos (79.06%).</a:t>
+              <a:t>Highest mean Test Per Class Accuracy: ViT Baseline (No Pos) (79.06%).</a:t>
             </a:r>
           </a:p>
           <a:p>
@@ -20881,7 +20881,7 @@
                 </a:solidFill>
                 <a:latin typeface="Aptos"/>
               </a:rPr>
-              <a:t>Highest mean Test Per Class F1: ViT Additive (34.95%).</a:t>
+              <a:t>Highest mean Test Per Class F1: ViT Additive Sinusoidal (34.95%).</a:t>
             </a:r>
           </a:p>
           <a:p>
@@ -21391,7 +21391,7 @@
                 </a:solidFill>
                 <a:latin typeface="Aptos"/>
               </a:rPr>
-              <a:t>Highest mean Test Per Class Precision: ViT Multiplicative (38.52%).</a:t>
+              <a:t>Highest mean Test Per Class Precision: ViT Multiplicative Sinusoidal (38.52%).</a:t>
             </a:r>
           </a:p>
           <a:p>
@@ -21901,7 +21901,7 @@
                 </a:solidFill>
                 <a:latin typeface="Aptos"/>
               </a:rPr>
-              <a:t>Highest mean Test Per Class Recall: ViT Baseline (34.80%).</a:t>
+              <a:t>Highest mean Test Per Class Recall: ViT Learnable Position (34.80%).</a:t>
             </a:r>
           </a:p>
           <a:p>
@@ -22254,7 +22254,7 @@
                 </a:solidFill>
                 <a:latin typeface="Aptos"/>
               </a:rPr>
-              <a:t>Current headline result: ViT No Pos leads on Test ACC with 79.48%.</a:t>
+              <a:t>Current headline result: ViT Baseline (No Pos) leads on Test ACC with 79.48%.</a:t>
             </a:r>
           </a:p>
           <a:p>
@@ -22273,7 +22273,7 @@
                 </a:solidFill>
                 <a:latin typeface="Aptos"/>
               </a:rPr>
-              <a:t>When presenting baseline vs comparison, use ViT No Pos as reference and report ViT Baseline at -0.51 pp on Test ACC.</a:t>
+              <a:t>When presenting baseline vs comparison, use ViT Baseline (No Pos) as reference and report ViT Learnable Position at -0.51 pp on Test ACC.</a:t>
             </a:r>
           </a:p>
           <a:p>
@@ -22949,7 +22949,7 @@
                 </a:solidFill>
                 <a:latin typeface="Aptos"/>
               </a:rPr>
-              <a:t>ViT Additive</a:t>
+              <a:t>ViT Additive Sinusoidal</a:t>
             </a:r>
           </a:p>
         </p:txBody>
@@ -23219,7 +23219,7 @@
                 </a:solidFill>
                 <a:latin typeface="Aptos"/>
               </a:rPr>
-              <a:t>ViT Additive Shifted</a:t>
+              <a:t>ViT Additive Sinusoidal Shifted</a:t>
             </a:r>
           </a:p>
         </p:txBody>
@@ -23489,7 +23489,7 @@
                 </a:solidFill>
                 <a:latin typeface="Aptos"/>
               </a:rPr>
-              <a:t>ViT Multiplicative</a:t>
+              <a:t>ViT Multiplicative Sinusoidal</a:t>
             </a:r>
           </a:p>
         </p:txBody>
@@ -23759,7 +23759,7 @@
                 </a:solidFill>
                 <a:latin typeface="Aptos"/>
               </a:rPr>
-              <a:t>ViT Multiplicative Shifted</a:t>
+              <a:t>ViT Multiplicative Sinusoidal Shifted</a:t>
             </a:r>
           </a:p>
         </p:txBody>
@@ -24275,7 +24275,7 @@
                 </a:solidFill>
                 <a:latin typeface="Aptos"/>
               </a:rPr>
-              <a:t>Primary comparison metric: Test ACC. Best final result is ViT No Pos with 79.48%.</a:t>
+              <a:t>Primary comparison metric: Test ACC. Best final result is ViT Baseline (No Pos) with 79.48%.</a:t>
             </a:r>
           </a:p>
           <a:p>
@@ -24294,7 +24294,7 @@
                 </a:solidFill>
                 <a:latin typeface="Aptos"/>
               </a:rPr>
-              <a:t>Largest train-to-test accuracy gap appears in ViT Additive Shifted (22.83 pp), worth calling out during generalization discussion.</a:t>
+              <a:t>Largest train-to-test accuracy gap appears in ViT Additive Sinusoidal Shifted (22.83 pp), worth calling out during generalization discussion.</a:t>
             </a:r>
           </a:p>
           <a:p>
@@ -24313,7 +24313,7 @@
                 </a:solidFill>
                 <a:latin typeface="Aptos"/>
               </a:rPr>
-              <a:t>Early stopping summary: ViT No Pos: stopped early; ViT Baseline: stopped early; ViT Row-wise: stopped early</a:t>
+              <a:t>Early stopping summary: ViT Baseline (No Pos): stopped early; ViT Learnable Position: stopped early; ViT Row-wise Sinusoidal: stopped early</a:t>
             </a:r>
           </a:p>
         </p:txBody>
@@ -24448,7 +24448,7 @@
                 </a:solidFill>
                 <a:latin typeface="Aptos"/>
               </a:rPr>
-              <a:t>ViT No Pos</a:t>
+              <a:t>ViT Baseline (No Pos)</a:t>
             </a:r>
           </a:p>
         </p:txBody>
@@ -25386,7 +25386,7 @@
                           </a:solidFill>
                           <a:latin typeface="Aptos"/>
                         </a:rPr>
-                        <a:t>ViT No Pos</a:t>
+                        <a:t>ViT Baseline (No Pos)</a:t>
                       </a:r>
                     </a:p>
                   </a:txBody>
@@ -25413,7 +25413,7 @@
                           </a:solidFill>
                           <a:latin typeface="Aptos"/>
                         </a:rPr>
-                        <a:t>ViT No Pos</a:t>
+                        <a:t>ViT Baseline (No Pos)</a:t>
                       </a:r>
                     </a:p>
                   </a:txBody>
@@ -25467,7 +25467,7 @@
                           </a:solidFill>
                           <a:latin typeface="Aptos"/>
                         </a:rPr>
-                        <a:t>No Pos</a:t>
+                        <a:t>Baseline (No Pos)</a:t>
                       </a:r>
                     </a:p>
                   </a:txBody>
@@ -25577,7 +25577,7 @@
                           </a:solidFill>
                           <a:latin typeface="Aptos"/>
                         </a:rPr>
-                        <a:t>ViT Baseline</a:t>
+                        <a:t>ViT Learnable Position</a:t>
                       </a:r>
                     </a:p>
                   </a:txBody>
@@ -25604,7 +25604,7 @@
                           </a:solidFill>
                           <a:latin typeface="Aptos"/>
                         </a:rPr>
-                        <a:t>ViT Baseline</a:t>
+                        <a:t>ViT Learnable Position</a:t>
                       </a:r>
                     </a:p>
                   </a:txBody>
@@ -25658,7 +25658,7 @@
                           </a:solidFill>
                           <a:latin typeface="Aptos"/>
                         </a:rPr>
-                        <a:t>Baseline</a:t>
+                        <a:t>Learnable Position</a:t>
                       </a:r>
                     </a:p>
                   </a:txBody>
@@ -25768,7 +25768,7 @@
                           </a:solidFill>
                           <a:latin typeface="Aptos"/>
                         </a:rPr>
-                        <a:t>ViT Row-wise</a:t>
+                        <a:t>ViT Row-wise Sinusoidal</a:t>
                       </a:r>
                     </a:p>
                   </a:txBody>
@@ -25959,7 +25959,7 @@
                           </a:solidFill>
                           <a:latin typeface="Aptos"/>
                         </a:rPr>
-                        <a:t>ViT Column-wise</a:t>
+                        <a:t>ViT Column-wise Sinusoidal</a:t>
                       </a:r>
                     </a:p>
                   </a:txBody>
@@ -26150,7 +26150,7 @@
                           </a:solidFill>
                           <a:latin typeface="Aptos"/>
                         </a:rPr>
-                        <a:t>ViT Additive</a:t>
+                        <a:t>ViT Additive Sinusoidal</a:t>
                       </a:r>
                     </a:p>
                   </a:txBody>
@@ -26341,7 +26341,7 @@
                           </a:solidFill>
                           <a:latin typeface="Aptos"/>
                         </a:rPr>
-                        <a:t>ViT Additive Shifted</a:t>
+                        <a:t>ViT Additive Sinusoidal Shifted</a:t>
                       </a:r>
                     </a:p>
                   </a:txBody>
@@ -26532,7 +26532,7 @@
                           </a:solidFill>
                           <a:latin typeface="Aptos"/>
                         </a:rPr>
-                        <a:t>ViT Multiplicative</a:t>
+                        <a:t>ViT Multiplicative Sinusoidal</a:t>
                       </a:r>
                     </a:p>
                   </a:txBody>
@@ -27237,7 +27237,7 @@
                           </a:solidFill>
                           <a:latin typeface="Aptos"/>
                         </a:rPr>
-                        <a:t>ViT Multiplicative Shifted</a:t>
+                        <a:t>ViT Multiplicative Sinusoidal Shifted</a:t>
                       </a:r>
                     </a:p>
                   </a:txBody>
@@ -27970,7 +27970,7 @@
                           </a:solidFill>
                           <a:latin typeface="Aptos"/>
                         </a:rPr>
-                        <a:t>ViT No Pos</a:t>
+                        <a:t>ViT Baseline (No Pos)</a:t>
                       </a:r>
                     </a:p>
                   </a:txBody>
@@ -27997,7 +27997,7 @@
                           </a:solidFill>
                           <a:latin typeface="Aptos"/>
                         </a:rPr>
-                        <a:t>ViT No Pos</a:t>
+                        <a:t>ViT Baseline (No Pos)</a:t>
                       </a:r>
                     </a:p>
                   </a:txBody>
@@ -28024,7 +28024,7 @@
                           </a:solidFill>
                           <a:latin typeface="Aptos"/>
                         </a:rPr>
-                        <a:t>No Pos</a:t>
+                        <a:t>Baseline (No Pos)</a:t>
                       </a:r>
                     </a:p>
                   </a:txBody>
@@ -28188,7 +28188,7 @@
                           </a:solidFill>
                           <a:latin typeface="Aptos"/>
                         </a:rPr>
-                        <a:t>ViT Baseline</a:t>
+                        <a:t>ViT Learnable Position</a:t>
                       </a:r>
                     </a:p>
                   </a:txBody>
@@ -28215,7 +28215,7 @@
                           </a:solidFill>
                           <a:latin typeface="Aptos"/>
                         </a:rPr>
-                        <a:t>ViT Baseline</a:t>
+                        <a:t>ViT Learnable Position</a:t>
                       </a:r>
                     </a:p>
                   </a:txBody>
@@ -28242,7 +28242,7 @@
                           </a:solidFill>
                           <a:latin typeface="Aptos"/>
                         </a:rPr>
-                        <a:t>Baseline</a:t>
+                        <a:t>Learnable Position</a:t>
                       </a:r>
                     </a:p>
                   </a:txBody>
@@ -28406,7 +28406,7 @@
                           </a:solidFill>
                           <a:latin typeface="Aptos"/>
                         </a:rPr>
-                        <a:t>ViT Row-wise</a:t>
+                        <a:t>ViT Row-wise Sinusoidal</a:t>
                       </a:r>
                     </a:p>
                   </a:txBody>
@@ -28624,7 +28624,7 @@
                           </a:solidFill>
                           <a:latin typeface="Aptos"/>
                         </a:rPr>
-                        <a:t>ViT Column-wise</a:t>
+                        <a:t>ViT Column-wise Sinusoidal</a:t>
                       </a:r>
                     </a:p>
                   </a:txBody>
@@ -28842,7 +28842,7 @@
                           </a:solidFill>
                           <a:latin typeface="Aptos"/>
                         </a:rPr>
-                        <a:t>ViT Additive</a:t>
+                        <a:t>ViT Additive Sinusoidal</a:t>
                       </a:r>
                     </a:p>
                   </a:txBody>
@@ -29060,7 +29060,7 @@
                           </a:solidFill>
                           <a:latin typeface="Aptos"/>
                         </a:rPr>
-                        <a:t>ViT Additive Shifted</a:t>
+                        <a:t>ViT Additive Sinusoidal Shifted</a:t>
                       </a:r>
                     </a:p>
                   </a:txBody>
@@ -29278,7 +29278,7 @@
                           </a:solidFill>
                           <a:latin typeface="Aptos"/>
                         </a:rPr>
-                        <a:t>ViT Multiplicative</a:t>
+                        <a:t>ViT Multiplicative Sinusoidal</a:t>
                       </a:r>
                     </a:p>
                   </a:txBody>
@@ -30038,7 +30038,7 @@
                           </a:solidFill>
                           <a:latin typeface="Aptos"/>
                         </a:rPr>
-                        <a:t>ViT Multiplicative Shifted</a:t>
+                        <a:t>ViT Multiplicative Sinusoidal Shifted</a:t>
                       </a:r>
                     </a:p>
                   </a:txBody>
@@ -30632,7 +30632,7 @@
                           </a:solidFill>
                           <a:latin typeface="Aptos"/>
                         </a:rPr>
-                        <a:t>ViT No Pos</a:t>
+                        <a:t>ViT Baseline (No Pos)</a:t>
                       </a:r>
                     </a:p>
                   </a:txBody>
@@ -30659,7 +30659,7 @@
                           </a:solidFill>
                           <a:latin typeface="Aptos"/>
                         </a:rPr>
-                        <a:t>ViT Baseline</a:t>
+                        <a:t>ViT Learnable Position</a:t>
                       </a:r>
                     </a:p>
                   </a:txBody>
@@ -30686,7 +30686,7 @@
                           </a:solidFill>
                           <a:latin typeface="Aptos"/>
                         </a:rPr>
-                        <a:t>ViT Row-wise</a:t>
+                        <a:t>ViT Row-wise Sinusoidal</a:t>
                       </a:r>
                     </a:p>
                   </a:txBody>
@@ -30713,7 +30713,7 @@
                           </a:solidFill>
                           <a:latin typeface="Aptos"/>
                         </a:rPr>
-                        <a:t>ViT Column-wise</a:t>
+                        <a:t>ViT Column-wise Sinusoidal</a:t>
                       </a:r>
                     </a:p>
                   </a:txBody>

</xml_diff>